<commit_message>
lab1 + lecture1 content update
</commit_message>
<xml_diff>
--- a/labs/Mobile-and-Embedded-Lab1.pptx
+++ b/labs/Mobile-and-Embedded-Lab1.pptx
@@ -212,7 +212,7 @@
           <a:p>
             <a:fld id="{03371807-75D2-4B48-9BC1-C0791C7EACC9}" type="datetimeFigureOut">
               <a:rPr lang="en-US" smtClean="0"/>
-              <a:t>3/3/26</a:t>
+              <a:t>3/24/26</a:t>
             </a:fld>
             <a:endParaRPr lang="en-US"/>
           </a:p>
@@ -626,7 +626,7 @@
           <a:p>
             <a:fld id="{779551AF-0EE3-DD4B-B4EF-6D8229EA0D86}" type="datetimeFigureOut">
               <a:rPr lang="en-US" smtClean="0"/>
-              <a:t>3/3/26</a:t>
+              <a:t>3/24/26</a:t>
             </a:fld>
             <a:endParaRPr lang="en-US"/>
           </a:p>
@@ -824,7 +824,7 @@
           <a:p>
             <a:fld id="{779551AF-0EE3-DD4B-B4EF-6D8229EA0D86}" type="datetimeFigureOut">
               <a:rPr lang="en-US" smtClean="0"/>
-              <a:t>3/3/26</a:t>
+              <a:t>3/24/26</a:t>
             </a:fld>
             <a:endParaRPr lang="en-US"/>
           </a:p>
@@ -1032,7 +1032,7 @@
           <a:p>
             <a:fld id="{779551AF-0EE3-DD4B-B4EF-6D8229EA0D86}" type="datetimeFigureOut">
               <a:rPr lang="en-US" smtClean="0"/>
-              <a:t>3/3/26</a:t>
+              <a:t>3/24/26</a:t>
             </a:fld>
             <a:endParaRPr lang="en-US"/>
           </a:p>
@@ -1230,7 +1230,7 @@
           <a:p>
             <a:fld id="{779551AF-0EE3-DD4B-B4EF-6D8229EA0D86}" type="datetimeFigureOut">
               <a:rPr lang="en-US" smtClean="0"/>
-              <a:t>3/3/26</a:t>
+              <a:t>3/24/26</a:t>
             </a:fld>
             <a:endParaRPr lang="en-US"/>
           </a:p>
@@ -1505,7 +1505,7 @@
           <a:p>
             <a:fld id="{779551AF-0EE3-DD4B-B4EF-6D8229EA0D86}" type="datetimeFigureOut">
               <a:rPr lang="en-US" smtClean="0"/>
-              <a:t>3/3/26</a:t>
+              <a:t>3/24/26</a:t>
             </a:fld>
             <a:endParaRPr lang="en-US"/>
           </a:p>
@@ -1770,7 +1770,7 @@
           <a:p>
             <a:fld id="{779551AF-0EE3-DD4B-B4EF-6D8229EA0D86}" type="datetimeFigureOut">
               <a:rPr lang="en-US" smtClean="0"/>
-              <a:t>3/3/26</a:t>
+              <a:t>3/24/26</a:t>
             </a:fld>
             <a:endParaRPr lang="en-US"/>
           </a:p>
@@ -2182,7 +2182,7 @@
           <a:p>
             <a:fld id="{779551AF-0EE3-DD4B-B4EF-6D8229EA0D86}" type="datetimeFigureOut">
               <a:rPr lang="en-US" smtClean="0"/>
-              <a:t>3/3/26</a:t>
+              <a:t>3/24/26</a:t>
             </a:fld>
             <a:endParaRPr lang="en-US"/>
           </a:p>
@@ -2323,7 +2323,7 @@
           <a:p>
             <a:fld id="{779551AF-0EE3-DD4B-B4EF-6D8229EA0D86}" type="datetimeFigureOut">
               <a:rPr lang="en-US" smtClean="0"/>
-              <a:t>3/3/26</a:t>
+              <a:t>3/24/26</a:t>
             </a:fld>
             <a:endParaRPr lang="en-US"/>
           </a:p>
@@ -2436,7 +2436,7 @@
           <a:p>
             <a:fld id="{779551AF-0EE3-DD4B-B4EF-6D8229EA0D86}" type="datetimeFigureOut">
               <a:rPr lang="en-US" smtClean="0"/>
-              <a:t>3/3/26</a:t>
+              <a:t>3/24/26</a:t>
             </a:fld>
             <a:endParaRPr lang="en-US"/>
           </a:p>
@@ -2747,7 +2747,7 @@
           <a:p>
             <a:fld id="{779551AF-0EE3-DD4B-B4EF-6D8229EA0D86}" type="datetimeFigureOut">
               <a:rPr lang="en-US" smtClean="0"/>
-              <a:t>3/3/26</a:t>
+              <a:t>3/24/26</a:t>
             </a:fld>
             <a:endParaRPr lang="en-US"/>
           </a:p>
@@ -3035,7 +3035,7 @@
           <a:p>
             <a:fld id="{779551AF-0EE3-DD4B-B4EF-6D8229EA0D86}" type="datetimeFigureOut">
               <a:rPr lang="en-US" smtClean="0"/>
-              <a:t>3/3/26</a:t>
+              <a:t>3/24/26</a:t>
             </a:fld>
             <a:endParaRPr lang="en-US"/>
           </a:p>
@@ -3276,7 +3276,7 @@
           <a:p>
             <a:fld id="{779551AF-0EE3-DD4B-B4EF-6D8229EA0D86}" type="datetimeFigureOut">
               <a:rPr lang="en-US" smtClean="0"/>
-              <a:t>3/3/26</a:t>
+              <a:t>3/24/26</a:t>
             </a:fld>
             <a:endParaRPr lang="en-US"/>
           </a:p>
@@ -3824,10 +3824,16 @@
               <a:buNone/>
             </a:pPr>
             <a:r>
+              <a:rPr lang="en-US" sz="3500" b="1">
+                <a:cs typeface="Al Bayan Plain" pitchFamily="2" charset="-78"/>
+              </a:rPr>
+              <a:t>Dinu-Ștefan RUSU 	</a:t>
+            </a:r>
+            <a:r>
               <a:rPr lang="en-US" sz="3500" b="1" dirty="0">
                 <a:cs typeface="Al Bayan Plain" pitchFamily="2" charset="-78"/>
               </a:rPr>
-              <a:t>Ing. Dinu-Ștefan RUSU 					</a:t>
+              <a:t>					</a:t>
             </a:r>
             <a:r>
               <a:rPr lang="en-US" dirty="0">

</xml_diff>

<commit_message>
added github link detail to project presentation
</commit_message>
<xml_diff>
--- a/labs/Mobile-and-Embedded-Lab1.pptx
+++ b/labs/Mobile-and-Embedded-Lab1.pptx
@@ -212,7 +212,7 @@
           <a:p>
             <a:fld id="{03371807-75D2-4B48-9BC1-C0791C7EACC9}" type="datetimeFigureOut">
               <a:rPr lang="en-US" smtClean="0"/>
-              <a:t>3/24/26</a:t>
+              <a:t>5/4/26</a:t>
             </a:fld>
             <a:endParaRPr lang="en-US"/>
           </a:p>
@@ -626,7 +626,7 @@
           <a:p>
             <a:fld id="{779551AF-0EE3-DD4B-B4EF-6D8229EA0D86}" type="datetimeFigureOut">
               <a:rPr lang="en-US" smtClean="0"/>
-              <a:t>3/24/26</a:t>
+              <a:t>5/4/26</a:t>
             </a:fld>
             <a:endParaRPr lang="en-US"/>
           </a:p>
@@ -824,7 +824,7 @@
           <a:p>
             <a:fld id="{779551AF-0EE3-DD4B-B4EF-6D8229EA0D86}" type="datetimeFigureOut">
               <a:rPr lang="en-US" smtClean="0"/>
-              <a:t>3/24/26</a:t>
+              <a:t>5/4/26</a:t>
             </a:fld>
             <a:endParaRPr lang="en-US"/>
           </a:p>
@@ -1032,7 +1032,7 @@
           <a:p>
             <a:fld id="{779551AF-0EE3-DD4B-B4EF-6D8229EA0D86}" type="datetimeFigureOut">
               <a:rPr lang="en-US" smtClean="0"/>
-              <a:t>3/24/26</a:t>
+              <a:t>5/4/26</a:t>
             </a:fld>
             <a:endParaRPr lang="en-US"/>
           </a:p>
@@ -1230,7 +1230,7 @@
           <a:p>
             <a:fld id="{779551AF-0EE3-DD4B-B4EF-6D8229EA0D86}" type="datetimeFigureOut">
               <a:rPr lang="en-US" smtClean="0"/>
-              <a:t>3/24/26</a:t>
+              <a:t>5/4/26</a:t>
             </a:fld>
             <a:endParaRPr lang="en-US"/>
           </a:p>
@@ -1505,7 +1505,7 @@
           <a:p>
             <a:fld id="{779551AF-0EE3-DD4B-B4EF-6D8229EA0D86}" type="datetimeFigureOut">
               <a:rPr lang="en-US" smtClean="0"/>
-              <a:t>3/24/26</a:t>
+              <a:t>5/4/26</a:t>
             </a:fld>
             <a:endParaRPr lang="en-US"/>
           </a:p>
@@ -1770,7 +1770,7 @@
           <a:p>
             <a:fld id="{779551AF-0EE3-DD4B-B4EF-6D8229EA0D86}" type="datetimeFigureOut">
               <a:rPr lang="en-US" smtClean="0"/>
-              <a:t>3/24/26</a:t>
+              <a:t>5/4/26</a:t>
             </a:fld>
             <a:endParaRPr lang="en-US"/>
           </a:p>
@@ -2182,7 +2182,7 @@
           <a:p>
             <a:fld id="{779551AF-0EE3-DD4B-B4EF-6D8229EA0D86}" type="datetimeFigureOut">
               <a:rPr lang="en-US" smtClean="0"/>
-              <a:t>3/24/26</a:t>
+              <a:t>5/4/26</a:t>
             </a:fld>
             <a:endParaRPr lang="en-US"/>
           </a:p>
@@ -2323,7 +2323,7 @@
           <a:p>
             <a:fld id="{779551AF-0EE3-DD4B-B4EF-6D8229EA0D86}" type="datetimeFigureOut">
               <a:rPr lang="en-US" smtClean="0"/>
-              <a:t>3/24/26</a:t>
+              <a:t>5/4/26</a:t>
             </a:fld>
             <a:endParaRPr lang="en-US"/>
           </a:p>
@@ -2436,7 +2436,7 @@
           <a:p>
             <a:fld id="{779551AF-0EE3-DD4B-B4EF-6D8229EA0D86}" type="datetimeFigureOut">
               <a:rPr lang="en-US" smtClean="0"/>
-              <a:t>3/24/26</a:t>
+              <a:t>5/4/26</a:t>
             </a:fld>
             <a:endParaRPr lang="en-US"/>
           </a:p>
@@ -2747,7 +2747,7 @@
           <a:p>
             <a:fld id="{779551AF-0EE3-DD4B-B4EF-6D8229EA0D86}" type="datetimeFigureOut">
               <a:rPr lang="en-US" smtClean="0"/>
-              <a:t>3/24/26</a:t>
+              <a:t>5/4/26</a:t>
             </a:fld>
             <a:endParaRPr lang="en-US"/>
           </a:p>
@@ -3035,7 +3035,7 @@
           <a:p>
             <a:fld id="{779551AF-0EE3-DD4B-B4EF-6D8229EA0D86}" type="datetimeFigureOut">
               <a:rPr lang="en-US" smtClean="0"/>
-              <a:t>3/24/26</a:t>
+              <a:t>5/4/26</a:t>
             </a:fld>
             <a:endParaRPr lang="en-US"/>
           </a:p>
@@ -3276,7 +3276,7 @@
           <a:p>
             <a:fld id="{779551AF-0EE3-DD4B-B4EF-6D8229EA0D86}" type="datetimeFigureOut">
               <a:rPr lang="en-US" smtClean="0"/>
-              <a:t>3/24/26</a:t>
+              <a:t>5/4/26</a:t>
             </a:fld>
             <a:endParaRPr lang="en-US"/>
           </a:p>
@@ -4995,8 +4995,8 @@
         </p:nvSpPr>
         <p:spPr>
           <a:xfrm>
-            <a:off x="827186" y="1720840"/>
-            <a:ext cx="10537627" cy="3416320"/>
+            <a:off x="827186" y="1351508"/>
+            <a:ext cx="10537627" cy="4154984"/>
           </a:xfrm>
           <a:prstGeom prst="rect">
             <a:avLst/>
@@ -5060,6 +5060,32 @@
             <a:r>
               <a:rPr lang="en-US" sz="2400" dirty="0"/>
               <a:t>of the implemented app (what it does, what ‘screens’ it has,  etc.)</a:t>
+            </a:r>
+          </a:p>
+          <a:p>
+            <a:pPr lvl="1">
+              <a:buFont typeface="Wingdings" pitchFamily="2" charset="2"/>
+              <a:buChar char="Ø"/>
+            </a:pPr>
+            <a:r>
+              <a:rPr lang="en-US" sz="2400" dirty="0"/>
+              <a:t> </a:t>
+            </a:r>
+            <a:r>
+              <a:rPr lang="en-US" sz="2400" b="1" dirty="0"/>
+              <a:t>Link to the public GitHub repository </a:t>
+            </a:r>
+            <a:r>
+              <a:rPr lang="en-US" sz="2400" dirty="0"/>
+              <a:t>(or if you chose to make the repo private, make sure to invite me as a collaborator, my username is: </a:t>
+            </a:r>
+            <a:r>
+              <a:rPr lang="en-US" sz="2400" dirty="0" err="1"/>
+              <a:t>rusudinu</a:t>
+            </a:r>
+            <a:r>
+              <a:rPr lang="en-US" sz="2400" dirty="0"/>
+              <a:t>)</a:t>
             </a:r>
           </a:p>
           <a:p>

</xml_diff>